<commit_message>
Declare jszip in v1's package.json
oi_deck_builder.js requires jszip at two places (graftOntoTemplate and
injectSvgPreviews) but never declared it. It resolved only because pptxgenjs
happens to hoist jszip into node_modules -- so a clean `npm install` after any
pptxgenjs change that drops or nests that dependency would break both the
template graft and the SVG preview repair. v2 declares it correctly; v1 now
matches.

Co-Authored-By: Claude Opus 5 <noreply@anthropic.com>
</commit_message>
<xml_diff>
--- a/oi-slide-v2/decks/demo_ml/TreeModelsDemo.pptx
+++ b/oi-slide-v2/decks/demo_ml/TreeModelsDemo.pptx
@@ -2784,6 +2784,9 @@
           <a:lstStyle/>
           <a:p>
             <a:pPr algn="l" indent="0" marL="0">
+              <a:lnSpc>
+                <a:spcPct val="90000"/>
+              </a:lnSpc>
               <a:buNone/>
             </a:pPr>
             <a:r>
@@ -2823,6 +2826,9 @@
           <a:lstStyle/>
           <a:p>
             <a:pPr algn="l" indent="0" marL="0">
+              <a:lnSpc>
+                <a:spcPct val="90000"/>
+              </a:lnSpc>
               <a:buNone/>
             </a:pPr>
             <a:r>
@@ -3125,6 +3131,9 @@
           <a:lstStyle/>
           <a:p>
             <a:pPr algn="l" indent="0" marL="0">
+              <a:lnSpc>
+                <a:spcPct val="90000"/>
+              </a:lnSpc>
               <a:buNone/>
             </a:pPr>
             <a:r>
@@ -3164,6 +3173,9 @@
           <a:lstStyle/>
           <a:p>
             <a:pPr algn="l" indent="0" marL="0">
+              <a:lnSpc>
+                <a:spcPct val="90000"/>
+              </a:lnSpc>
               <a:buNone/>
             </a:pPr>
             <a:r>
@@ -3189,8 +3201,8 @@
         </p:nvSpPr>
         <p:spPr>
           <a:xfrm>
-            <a:off x="4624121" y="1475842"/>
-            <a:ext cx="2478024" cy="952805"/>
+            <a:off x="4801514" y="1369771"/>
+            <a:ext cx="2587752" cy="995782"/>
           </a:xfrm>
           <a:prstGeom prst="diamond">
             <a:avLst/>
@@ -3212,7 +3224,7 @@
               <a:buNone/>
             </a:pPr>
             <a:r>
-              <a:rPr lang="en-US" sz="1250" b="1" dirty="0">
+              <a:rPr lang="en-US" sz="1300" b="1" dirty="0">
                 <a:solidFill>
                   <a:srgbClr val="262626"/>
                 </a:solidFill>
@@ -3222,14 +3234,14 @@
               </a:rPr>
               <a:t>Parent income</a:t>
             </a:r>
-            <a:endParaRPr lang="en-US" sz="1250" dirty="0"/>
+            <a:endParaRPr lang="en-US" sz="1300" dirty="0"/>
           </a:p>
           <a:p>
             <a:pPr algn="ctr" indent="0" marL="0">
               <a:buNone/>
             </a:pPr>
             <a:r>
-              <a:rPr lang="en-US" sz="1250" b="1" dirty="0">
+              <a:rPr lang="en-US" sz="1300" b="1" dirty="0">
                 <a:solidFill>
                   <a:srgbClr val="262626"/>
                 </a:solidFill>
@@ -3239,7 +3251,7 @@
               </a:rPr>
               <a:t>&lt; $50k?</a:t>
             </a:r>
-            <a:endParaRPr lang="en-US" sz="1250" dirty="0"/>
+            <a:endParaRPr lang="en-US" sz="1300" dirty="0"/>
           </a:p>
         </p:txBody>
       </p:sp>
@@ -3251,8 +3263,8 @@
         </p:nvSpPr>
         <p:spPr>
           <a:xfrm flipH="1">
-            <a:off x="2907792" y="2381098"/>
-            <a:ext cx="2478024" cy="905256"/>
+            <a:off x="3010205" y="2316175"/>
+            <a:ext cx="2587752" cy="945490"/>
           </a:xfrm>
           <a:prstGeom prst="line">
             <a:avLst/>
@@ -3275,8 +3287,8 @@
         </p:nvSpPr>
         <p:spPr>
           <a:xfrm>
-            <a:off x="3575304" y="2520086"/>
-            <a:ext cx="1143914" cy="286207"/>
+            <a:off x="3706978" y="2459736"/>
+            <a:ext cx="1194206" cy="299009"/>
           </a:xfrm>
           <a:prstGeom prst="rect">
             <a:avLst/>
@@ -3292,7 +3304,7 @@
               <a:buNone/>
             </a:pPr>
             <a:r>
-              <a:rPr lang="en-US" sz="1250" dirty="0">
+              <a:rPr lang="en-US" sz="1300" dirty="0">
                 <a:solidFill>
                   <a:srgbClr val="262626"/>
                 </a:solidFill>
@@ -3302,7 +3314,7 @@
               </a:rPr>
               <a:t>Yes</a:t>
             </a:r>
-            <a:endParaRPr lang="en-US" sz="1250" dirty="0"/>
+            <a:endParaRPr lang="en-US" sz="1300" dirty="0"/>
           </a:p>
         </p:txBody>
       </p:sp>
@@ -3314,8 +3326,8 @@
         </p:nvSpPr>
         <p:spPr>
           <a:xfrm>
-            <a:off x="6339535" y="2381098"/>
-            <a:ext cx="2478024" cy="905256"/>
+            <a:off x="6593738" y="2316175"/>
+            <a:ext cx="2587752" cy="945490"/>
           </a:xfrm>
           <a:prstGeom prst="line">
             <a:avLst/>
@@ -3338,8 +3350,8 @@
         </p:nvSpPr>
         <p:spPr>
           <a:xfrm>
-            <a:off x="7006133" y="2520086"/>
-            <a:ext cx="1143914" cy="286207"/>
+            <a:off x="7290511" y="2459736"/>
+            <a:ext cx="1194206" cy="299009"/>
           </a:xfrm>
           <a:prstGeom prst="rect">
             <a:avLst/>
@@ -3355,7 +3367,7 @@
               <a:buNone/>
             </a:pPr>
             <a:r>
-              <a:rPr lang="en-US" sz="1250" dirty="0">
+              <a:rPr lang="en-US" sz="1300" dirty="0">
                 <a:solidFill>
                   <a:srgbClr val="262626"/>
                 </a:solidFill>
@@ -3365,7 +3377,7 @@
               </a:rPr>
               <a:t>No</a:t>
             </a:r>
-            <a:endParaRPr lang="en-US" sz="1250" dirty="0"/>
+            <a:endParaRPr lang="en-US" sz="1300" dirty="0"/>
           </a:p>
         </p:txBody>
       </p:sp>
@@ -3377,8 +3389,8 @@
         </p:nvSpPr>
         <p:spPr>
           <a:xfrm>
-            <a:off x="1478585" y="3287268"/>
-            <a:ext cx="2478024" cy="952805"/>
+            <a:off x="1516990" y="3261665"/>
+            <a:ext cx="2587752" cy="995782"/>
           </a:xfrm>
           <a:prstGeom prst="diamond">
             <a:avLst/>
@@ -3400,7 +3412,7 @@
               <a:buNone/>
             </a:pPr>
             <a:r>
-              <a:rPr lang="en-US" sz="1250" b="1" dirty="0">
+              <a:rPr lang="en-US" sz="1300" b="1" dirty="0">
                 <a:solidFill>
                   <a:srgbClr val="262626"/>
                 </a:solidFill>
@@ -3410,14 +3422,14 @@
               </a:rPr>
               <a:t>First-generation</a:t>
             </a:r>
-            <a:endParaRPr lang="en-US" sz="1250" dirty="0"/>
+            <a:endParaRPr lang="en-US" sz="1300" dirty="0"/>
           </a:p>
           <a:p>
             <a:pPr algn="ctr" indent="0" marL="0">
               <a:buNone/>
             </a:pPr>
             <a:r>
-              <a:rPr lang="en-US" sz="1250" b="1" dirty="0">
+              <a:rPr lang="en-US" sz="1300" b="1" dirty="0">
                 <a:solidFill>
                   <a:srgbClr val="262626"/>
                 </a:solidFill>
@@ -3427,7 +3439,7 @@
               </a:rPr>
               <a:t>student?</a:t>
             </a:r>
-            <a:endParaRPr lang="en-US" sz="1250" dirty="0"/>
+            <a:endParaRPr lang="en-US" sz="1300" dirty="0"/>
           </a:p>
         </p:txBody>
       </p:sp>
@@ -3439,8 +3451,8 @@
         </p:nvSpPr>
         <p:spPr>
           <a:xfrm>
-            <a:off x="7768742" y="3287268"/>
-            <a:ext cx="2478024" cy="952805"/>
+            <a:off x="8086954" y="3261665"/>
+            <a:ext cx="2587752" cy="995782"/>
           </a:xfrm>
           <a:prstGeom prst="diamond">
             <a:avLst/>
@@ -3462,7 +3474,7 @@
               <a:buNone/>
             </a:pPr>
             <a:r>
-              <a:rPr lang="en-US" sz="1250" b="1" dirty="0">
+              <a:rPr lang="en-US" sz="1300" b="1" dirty="0">
                 <a:solidFill>
                   <a:srgbClr val="262626"/>
                 </a:solidFill>
@@ -3472,14 +3484,14 @@
               </a:rPr>
               <a:t>Parent income</a:t>
             </a:r>
-            <a:endParaRPr lang="en-US" sz="1250" dirty="0"/>
+            <a:endParaRPr lang="en-US" sz="1300" dirty="0"/>
           </a:p>
           <a:p>
             <a:pPr algn="ctr" indent="0" marL="0">
               <a:buNone/>
             </a:pPr>
             <a:r>
-              <a:rPr lang="en-US" sz="1250" b="1" dirty="0">
+              <a:rPr lang="en-US" sz="1300" b="1" dirty="0">
                 <a:solidFill>
                   <a:srgbClr val="262626"/>
                 </a:solidFill>
@@ -3489,7 +3501,7 @@
               </a:rPr>
               <a:t>&lt; $100k?</a:t>
             </a:r>
-            <a:endParaRPr lang="en-US" sz="1250" dirty="0"/>
+            <a:endParaRPr lang="en-US" sz="1300" dirty="0"/>
           </a:p>
         </p:txBody>
       </p:sp>
@@ -3501,8 +3513,8 @@
         </p:nvSpPr>
         <p:spPr>
           <a:xfrm flipH="1">
-            <a:off x="1669694" y="4192524"/>
-            <a:ext cx="667512" cy="857707"/>
+            <a:off x="1716329" y="4207154"/>
+            <a:ext cx="696773" cy="896112"/>
           </a:xfrm>
           <a:prstGeom prst="line">
             <a:avLst/>
@@ -3525,8 +3537,8 @@
         </p:nvSpPr>
         <p:spPr>
           <a:xfrm>
-            <a:off x="1097280" y="4477817"/>
-            <a:ext cx="1143914" cy="286207"/>
+            <a:off x="1118311" y="4506163"/>
+            <a:ext cx="1194206" cy="299009"/>
           </a:xfrm>
           <a:prstGeom prst="rect">
             <a:avLst/>
@@ -3542,7 +3554,7 @@
               <a:buNone/>
             </a:pPr>
             <a:r>
-              <a:rPr lang="en-US" sz="1250" dirty="0">
+              <a:rPr lang="en-US" sz="1300" dirty="0">
                 <a:solidFill>
                   <a:srgbClr val="262626"/>
                 </a:solidFill>
@@ -3552,7 +3564,7 @@
               </a:rPr>
               <a:t>Yes</a:t>
             </a:r>
-            <a:endParaRPr lang="en-US" sz="1250" dirty="0"/>
+            <a:endParaRPr lang="en-US" sz="1300" dirty="0"/>
           </a:p>
         </p:txBody>
       </p:sp>
@@ -3564,8 +3576,8 @@
         </p:nvSpPr>
         <p:spPr>
           <a:xfrm>
-            <a:off x="3098902" y="4192524"/>
-            <a:ext cx="857707" cy="857707"/>
+            <a:off x="3208630" y="4207154"/>
+            <a:ext cx="896112" cy="896112"/>
           </a:xfrm>
           <a:prstGeom prst="line">
             <a:avLst/>
@@ -3588,8 +3600,8 @@
         </p:nvSpPr>
         <p:spPr>
           <a:xfrm>
-            <a:off x="3289097" y="4477817"/>
-            <a:ext cx="1143914" cy="286207"/>
+            <a:off x="3407969" y="4506163"/>
+            <a:ext cx="1194206" cy="299009"/>
           </a:xfrm>
           <a:prstGeom prst="rect">
             <a:avLst/>
@@ -3605,7 +3617,7 @@
               <a:buNone/>
             </a:pPr>
             <a:r>
-              <a:rPr lang="en-US" sz="1250" dirty="0">
+              <a:rPr lang="en-US" sz="1300" dirty="0">
                 <a:solidFill>
                   <a:srgbClr val="262626"/>
                 </a:solidFill>
@@ -3615,7 +3627,7 @@
               </a:rPr>
               <a:t>No</a:t>
             </a:r>
-            <a:endParaRPr lang="en-US" sz="1250" dirty="0"/>
+            <a:endParaRPr lang="en-US" sz="1300" dirty="0"/>
           </a:p>
         </p:txBody>
       </p:sp>
@@ -3627,8 +3639,8 @@
         </p:nvSpPr>
         <p:spPr>
           <a:xfrm flipH="1">
-            <a:off x="7959852" y="4192524"/>
-            <a:ext cx="667512" cy="857707"/>
+            <a:off x="8286293" y="4207154"/>
+            <a:ext cx="696773" cy="896112"/>
           </a:xfrm>
           <a:prstGeom prst="line">
             <a:avLst/>
@@ -3651,8 +3663,8 @@
         </p:nvSpPr>
         <p:spPr>
           <a:xfrm>
-            <a:off x="7387438" y="4477817"/>
-            <a:ext cx="1143914" cy="286207"/>
+            <a:off x="7688275" y="4506163"/>
+            <a:ext cx="1194206" cy="299009"/>
           </a:xfrm>
           <a:prstGeom prst="rect">
             <a:avLst/>
@@ -3668,7 +3680,7 @@
               <a:buNone/>
             </a:pPr>
             <a:r>
-              <a:rPr lang="en-US" sz="1250" dirty="0">
+              <a:rPr lang="en-US" sz="1300" dirty="0">
                 <a:solidFill>
                   <a:srgbClr val="262626"/>
                 </a:solidFill>
@@ -3678,7 +3690,7 @@
               </a:rPr>
               <a:t>Yes</a:t>
             </a:r>
-            <a:endParaRPr lang="en-US" sz="1250" dirty="0"/>
+            <a:endParaRPr lang="en-US" sz="1300" dirty="0"/>
           </a:p>
         </p:txBody>
       </p:sp>
@@ -3690,8 +3702,8 @@
         </p:nvSpPr>
         <p:spPr>
           <a:xfrm>
-            <a:off x="9389059" y="4192524"/>
-            <a:ext cx="762610" cy="857707"/>
+            <a:off x="9778594" y="4207154"/>
+            <a:ext cx="796442" cy="896112"/>
           </a:xfrm>
           <a:prstGeom prst="line">
             <a:avLst/>
@@ -3714,8 +3726,8 @@
         </p:nvSpPr>
         <p:spPr>
           <a:xfrm>
-            <a:off x="9531706" y="4477817"/>
-            <a:ext cx="1143914" cy="286207"/>
+            <a:off x="9928555" y="4506163"/>
+            <a:ext cx="1194206" cy="299009"/>
           </a:xfrm>
           <a:prstGeom prst="rect">
             <a:avLst/>
@@ -3731,7 +3743,7 @@
               <a:buNone/>
             </a:pPr>
             <a:r>
-              <a:rPr lang="en-US" sz="1250" dirty="0">
+              <a:rPr lang="en-US" sz="1300" dirty="0">
                 <a:solidFill>
                   <a:srgbClr val="262626"/>
                 </a:solidFill>
@@ -3741,7 +3753,7 @@
               </a:rPr>
               <a:t>No</a:t>
             </a:r>
-            <a:endParaRPr lang="en-US" sz="1250" dirty="0"/>
+            <a:endParaRPr lang="en-US" sz="1300" dirty="0"/>
           </a:p>
         </p:txBody>
       </p:sp>
@@ -3753,12 +3765,12 @@
         </p:nvSpPr>
         <p:spPr>
           <a:xfrm>
-            <a:off x="811073" y="5050231"/>
-            <a:ext cx="1715414" cy="667512"/>
+            <a:off x="820217" y="5103266"/>
+            <a:ext cx="1792224" cy="696773"/>
           </a:xfrm>
           <a:prstGeom prst="roundRect">
             <a:avLst>
-              <a:gd name="adj" fmla="val 8219"/>
+              <a:gd name="adj" fmla="val 7874"/>
             </a:avLst>
           </a:prstGeom>
           <a:solidFill>
@@ -3774,7 +3786,7 @@
               <a:buNone/>
             </a:pPr>
             <a:r>
-              <a:rPr lang="en-US" sz="1350" b="1" dirty="0">
+              <a:rPr lang="en-US" sz="1400" b="1" dirty="0">
                 <a:solidFill>
                   <a:srgbClr val="FFFFFF"/>
                 </a:solidFill>
@@ -3784,7 +3796,7 @@
               </a:rPr>
               <a:t>ŷ = $32k</a:t>
             </a:r>
-            <a:endParaRPr lang="en-US" sz="1350" dirty="0"/>
+            <a:endParaRPr lang="en-US" sz="1400" dirty="0"/>
           </a:p>
         </p:txBody>
       </p:sp>
@@ -3796,12 +3808,12 @@
         </p:nvSpPr>
         <p:spPr>
           <a:xfrm>
-            <a:off x="3098902" y="5050231"/>
-            <a:ext cx="1715414" cy="667512"/>
+            <a:off x="3208630" y="5103266"/>
+            <a:ext cx="1792224" cy="696773"/>
           </a:xfrm>
           <a:prstGeom prst="roundRect">
             <a:avLst>
-              <a:gd name="adj" fmla="val 8219"/>
+              <a:gd name="adj" fmla="val 7874"/>
             </a:avLst>
           </a:prstGeom>
           <a:solidFill>
@@ -3817,7 +3829,7 @@
               <a:buNone/>
             </a:pPr>
             <a:r>
-              <a:rPr lang="en-US" sz="1350" b="1" dirty="0">
+              <a:rPr lang="en-US" sz="1400" b="1" dirty="0">
                 <a:solidFill>
                   <a:srgbClr val="FFFFFF"/>
                 </a:solidFill>
@@ -3827,7 +3839,7 @@
               </a:rPr>
               <a:t>ŷ = $41k</a:t>
             </a:r>
-            <a:endParaRPr lang="en-US" sz="1350" dirty="0"/>
+            <a:endParaRPr lang="en-US" sz="1400" dirty="0"/>
           </a:p>
         </p:txBody>
       </p:sp>
@@ -3839,12 +3851,12 @@
         </p:nvSpPr>
         <p:spPr>
           <a:xfrm>
-            <a:off x="7101230" y="5050231"/>
-            <a:ext cx="1715414" cy="667512"/>
+            <a:off x="7390181" y="5103266"/>
+            <a:ext cx="1792224" cy="696773"/>
           </a:xfrm>
           <a:prstGeom prst="roundRect">
             <a:avLst>
-              <a:gd name="adj" fmla="val 8219"/>
+              <a:gd name="adj" fmla="val 7874"/>
             </a:avLst>
           </a:prstGeom>
           <a:solidFill>
@@ -3860,7 +3872,7 @@
               <a:buNone/>
             </a:pPr>
             <a:r>
-              <a:rPr lang="en-US" sz="1350" b="1" dirty="0">
+              <a:rPr lang="en-US" sz="1400" b="1" dirty="0">
                 <a:solidFill>
                   <a:srgbClr val="FFFFFF"/>
                 </a:solidFill>
@@ -3870,7 +3882,7 @@
               </a:rPr>
               <a:t>ŷ = $54k</a:t>
             </a:r>
-            <a:endParaRPr lang="en-US" sz="1350" dirty="0"/>
+            <a:endParaRPr lang="en-US" sz="1400" dirty="0"/>
           </a:p>
         </p:txBody>
       </p:sp>
@@ -3882,12 +3894,12 @@
         </p:nvSpPr>
         <p:spPr>
           <a:xfrm>
-            <a:off x="9293962" y="5050231"/>
-            <a:ext cx="1715414" cy="667512"/>
+            <a:off x="9679838" y="5103266"/>
+            <a:ext cx="1792224" cy="696773"/>
           </a:xfrm>
           <a:prstGeom prst="roundRect">
             <a:avLst>
-              <a:gd name="adj" fmla="val 8219"/>
+              <a:gd name="adj" fmla="val 7874"/>
             </a:avLst>
           </a:prstGeom>
           <a:solidFill>
@@ -3903,7 +3915,7 @@
               <a:buNone/>
             </a:pPr>
             <a:r>
-              <a:rPr lang="en-US" sz="1350" b="1" dirty="0">
+              <a:rPr lang="en-US" sz="1400" b="1" dirty="0">
                 <a:solidFill>
                   <a:srgbClr val="FFFFFF"/>
                 </a:solidFill>
@@ -3913,7 +3925,7 @@
               </a:rPr>
               <a:t>ŷ = $68k</a:t>
             </a:r>
-            <a:endParaRPr lang="en-US" sz="1350" dirty="0"/>
+            <a:endParaRPr lang="en-US" sz="1400" dirty="0"/>
           </a:p>
         </p:txBody>
       </p:sp>
@@ -3925,8 +3937,8 @@
         </p:nvSpPr>
         <p:spPr>
           <a:xfrm>
-            <a:off x="620878" y="5907938"/>
-            <a:ext cx="10483596" cy="381305"/>
+            <a:off x="620878" y="5999378"/>
+            <a:ext cx="10949940" cy="397764"/>
           </a:xfrm>
           <a:prstGeom prst="rect">
             <a:avLst/>
@@ -3942,7 +3954,7 @@
               <a:buNone/>
             </a:pPr>
             <a:r>
-              <a:rPr lang="en-US" sz="1250" i="1" dirty="0">
+              <a:rPr lang="en-US" sz="1300" i="1" dirty="0">
                 <a:solidFill>
                   <a:srgbClr val="626365"/>
                 </a:solidFill>
@@ -3952,7 +3964,7 @@
               </a:rPr>
               <a:t>Each split picks the variable and threshold that most reduce prediction error; each leaf predicts the average outcome (here: child income at age 30) for observations in that region.</a:t>
             </a:r>
-            <a:endParaRPr lang="en-US" sz="1250" dirty="0"/>
+            <a:endParaRPr lang="en-US" sz="1300" dirty="0"/>
           </a:p>
         </p:txBody>
       </p:sp>
@@ -4003,6 +4015,9 @@
           <a:lstStyle/>
           <a:p>
             <a:pPr algn="l" indent="0" marL="0">
+              <a:lnSpc>
+                <a:spcPct val="90000"/>
+              </a:lnSpc>
               <a:buNone/>
             </a:pPr>
             <a:r>
@@ -4042,6 +4057,9 @@
           <a:lstStyle/>
           <a:p>
             <a:pPr algn="l" indent="0" marL="0">
+              <a:lnSpc>
+                <a:spcPct val="90000"/>
+              </a:lnSpc>
               <a:buNone/>
             </a:pPr>
             <a:r>
@@ -4067,8 +4085,8 @@
         </p:nvSpPr>
         <p:spPr>
           <a:xfrm>
-            <a:off x="620878" y="1605686"/>
-            <a:ext cx="10483596" cy="414223"/>
+            <a:off x="620878" y="1505102"/>
+            <a:ext cx="10949940" cy="432511"/>
           </a:xfrm>
           <a:prstGeom prst="rect">
             <a:avLst/>
@@ -4084,7 +4102,7 @@
               <a:buNone/>
             </a:pPr>
             <a:r>
-              <a:rPr lang="en-US" sz="1500" b="1" dirty="0">
+              <a:rPr lang="en-US" sz="1600" b="1" dirty="0">
                 <a:solidFill>
                   <a:srgbClr val="262626"/>
                 </a:solidFill>
@@ -4094,7 +4112,7 @@
               </a:rPr>
               <a:t>Each new tree is trained on the mistakes (residuals) of the trees before it</a:t>
             </a:r>
-            <a:endParaRPr lang="en-US" sz="1500" dirty="0"/>
+            <a:endParaRPr lang="en-US" sz="1600" dirty="0"/>
           </a:p>
         </p:txBody>
       </p:sp>
@@ -4106,8 +4124,8 @@
         </p:nvSpPr>
         <p:spPr>
           <a:xfrm>
-            <a:off x="758952" y="3307385"/>
-            <a:ext cx="1563624" cy="919886"/>
+            <a:off x="765353" y="3282696"/>
+            <a:ext cx="1633118" cy="960120"/>
           </a:xfrm>
           <a:prstGeom prst="ellipse">
             <a:avLst/>
@@ -4129,7 +4147,7 @@
               <a:buNone/>
             </a:pPr>
             <a:r>
-              <a:rPr lang="en-US" sz="1200" b="1" dirty="0">
+              <a:rPr lang="en-US" sz="1250" b="1" dirty="0">
                 <a:solidFill>
                   <a:srgbClr val="262626"/>
                 </a:solidFill>
@@ -4139,14 +4157,14 @@
               </a:rPr>
               <a:t>Training data</a:t>
             </a:r>
-            <a:endParaRPr lang="en-US" sz="1200" dirty="0"/>
+            <a:endParaRPr lang="en-US" sz="1250" dirty="0"/>
           </a:p>
           <a:p>
             <a:pPr algn="ctr" indent="0" marL="0">
               <a:buNone/>
             </a:pPr>
             <a:r>
-              <a:rPr lang="en-US" sz="1200" b="1" dirty="0">
+              <a:rPr lang="en-US" sz="1250" b="1" dirty="0">
                 <a:solidFill>
                   <a:srgbClr val="262626"/>
                 </a:solidFill>
@@ -4156,7 +4174,7 @@
               </a:rPr>
               <a:t>(x, y)</a:t>
             </a:r>
-            <a:endParaRPr lang="en-US" sz="1200" dirty="0"/>
+            <a:endParaRPr lang="en-US" sz="1250" dirty="0"/>
           </a:p>
         </p:txBody>
       </p:sp>
@@ -4168,8 +4186,8 @@
         </p:nvSpPr>
         <p:spPr>
           <a:xfrm>
-            <a:off x="2368296" y="3766414"/>
-            <a:ext cx="919886" cy="0"/>
+            <a:off x="2446020" y="3762756"/>
+            <a:ext cx="960120" cy="0"/>
           </a:xfrm>
           <a:prstGeom prst="line">
             <a:avLst/>
@@ -4192,12 +4210,12 @@
         </p:nvSpPr>
         <p:spPr>
           <a:xfrm>
-            <a:off x="3288182" y="3260750"/>
-            <a:ext cx="1747418" cy="1011326"/>
+            <a:off x="3406140" y="3234233"/>
+            <a:ext cx="1825142" cy="1056132"/>
           </a:xfrm>
           <a:prstGeom prst="roundRect">
             <a:avLst>
-              <a:gd name="adj" fmla="val 5425"/>
+              <a:gd name="adj" fmla="val 5195"/>
             </a:avLst>
           </a:prstGeom>
           <a:solidFill>
@@ -4213,7 +4231,7 @@
               <a:buNone/>
             </a:pPr>
             <a:r>
-              <a:rPr lang="en-US" sz="1300" b="1" dirty="0">
+              <a:rPr lang="en-US" sz="1350" b="1" dirty="0">
                 <a:solidFill>
                   <a:srgbClr val="FFFFFF"/>
                 </a:solidFill>
@@ -4223,14 +4241,14 @@
               </a:rPr>
               <a:t>Tree 1</a:t>
             </a:r>
-            <a:endParaRPr lang="en-US" sz="1300" dirty="0"/>
+            <a:endParaRPr lang="en-US" sz="1350" dirty="0"/>
           </a:p>
           <a:p>
             <a:pPr algn="ctr" indent="0" marL="0">
               <a:buNone/>
             </a:pPr>
             <a:r>
-              <a:rPr lang="en-US" sz="1300" b="1" dirty="0">
+              <a:rPr lang="en-US" sz="1350" b="1" dirty="0">
                 <a:solidFill>
                   <a:srgbClr val="FFFFFF"/>
                 </a:solidFill>
@@ -4240,7 +4258,7 @@
               </a:rPr>
               <a:t>f₁(x)</a:t>
             </a:r>
-            <a:endParaRPr lang="en-US" sz="1300" dirty="0"/>
+            <a:endParaRPr lang="en-US" sz="1350" dirty="0"/>
           </a:p>
         </p:txBody>
       </p:sp>
@@ -4252,8 +4270,8 @@
         </p:nvSpPr>
         <p:spPr>
           <a:xfrm>
-            <a:off x="3103474" y="4410151"/>
-            <a:ext cx="2115007" cy="321869"/>
+            <a:off x="3214116" y="4434840"/>
+            <a:ext cx="2209190" cy="336499"/>
           </a:xfrm>
           <a:prstGeom prst="rect">
             <a:avLst/>
@@ -4269,7 +4287,7 @@
               <a:buNone/>
             </a:pPr>
             <a:r>
-              <a:rPr lang="en-US" sz="1100" dirty="0">
+              <a:rPr lang="en-US" sz="1150" dirty="0">
                 <a:solidFill>
                   <a:srgbClr val="626365"/>
                 </a:solidFill>
@@ -4279,7 +4297,7 @@
               </a:rPr>
               <a:t>fits the outcome y</a:t>
             </a:r>
-            <a:endParaRPr lang="en-US" sz="1100" dirty="0"/>
+            <a:endParaRPr lang="en-US" sz="1150" dirty="0"/>
           </a:p>
         </p:txBody>
       </p:sp>
@@ -4291,8 +4309,8 @@
         </p:nvSpPr>
         <p:spPr>
           <a:xfrm>
-            <a:off x="5081321" y="3766414"/>
-            <a:ext cx="1103681" cy="0"/>
+            <a:off x="5279746" y="3762756"/>
+            <a:ext cx="1153058" cy="0"/>
           </a:xfrm>
           <a:prstGeom prst="line">
             <a:avLst/>
@@ -4315,8 +4333,8 @@
         </p:nvSpPr>
         <p:spPr>
           <a:xfrm>
-            <a:off x="4805172" y="3334817"/>
-            <a:ext cx="1655064" cy="276149"/>
+            <a:off x="4990795" y="3311042"/>
+            <a:ext cx="1729130" cy="288036"/>
           </a:xfrm>
           <a:prstGeom prst="rect">
             <a:avLst/>
@@ -4332,7 +4350,7 @@
               <a:buNone/>
             </a:pPr>
             <a:r>
-              <a:rPr lang="en-US" sz="1100" dirty="0">
+              <a:rPr lang="en-US" sz="1150" dirty="0">
                 <a:solidFill>
                   <a:srgbClr val="262626"/>
                 </a:solidFill>
@@ -4342,7 +4360,7 @@
               </a:rPr>
               <a:t>r₁ = y − f₁(x)</a:t>
             </a:r>
-            <a:endParaRPr lang="en-US" sz="1100" dirty="0"/>
+            <a:endParaRPr lang="en-US" sz="1150" dirty="0"/>
           </a:p>
         </p:txBody>
       </p:sp>
@@ -4354,12 +4372,12 @@
         </p:nvSpPr>
         <p:spPr>
           <a:xfrm>
-            <a:off x="6184087" y="3260750"/>
-            <a:ext cx="1747418" cy="1011326"/>
+            <a:off x="6431890" y="3234233"/>
+            <a:ext cx="1825142" cy="1056132"/>
           </a:xfrm>
           <a:prstGeom prst="roundRect">
             <a:avLst>
-              <a:gd name="adj" fmla="val 5425"/>
+              <a:gd name="adj" fmla="val 5195"/>
             </a:avLst>
           </a:prstGeom>
           <a:solidFill>
@@ -4375,7 +4393,7 @@
               <a:buNone/>
             </a:pPr>
             <a:r>
-              <a:rPr lang="en-US" sz="1300" b="1" dirty="0">
+              <a:rPr lang="en-US" sz="1350" b="1" dirty="0">
                 <a:solidFill>
                   <a:srgbClr val="FFFFFF"/>
                 </a:solidFill>
@@ -4385,14 +4403,14 @@
               </a:rPr>
               <a:t>Tree 2</a:t>
             </a:r>
-            <a:endParaRPr lang="en-US" sz="1300" dirty="0"/>
+            <a:endParaRPr lang="en-US" sz="1350" dirty="0"/>
           </a:p>
           <a:p>
             <a:pPr algn="ctr" indent="0" marL="0">
               <a:buNone/>
             </a:pPr>
             <a:r>
-              <a:rPr lang="en-US" sz="1300" b="1" dirty="0">
+              <a:rPr lang="en-US" sz="1350" b="1" dirty="0">
                 <a:solidFill>
                   <a:srgbClr val="FFFFFF"/>
                 </a:solidFill>
@@ -4402,7 +4420,7 @@
               </a:rPr>
               <a:t>f₂(x)</a:t>
             </a:r>
-            <a:endParaRPr lang="en-US" sz="1300" dirty="0"/>
+            <a:endParaRPr lang="en-US" sz="1350" dirty="0"/>
           </a:p>
         </p:txBody>
       </p:sp>
@@ -4414,8 +4432,8 @@
         </p:nvSpPr>
         <p:spPr>
           <a:xfrm>
-            <a:off x="6000293" y="4410151"/>
-            <a:ext cx="2115007" cy="321869"/>
+            <a:off x="6239866" y="4434840"/>
+            <a:ext cx="2209190" cy="336499"/>
           </a:xfrm>
           <a:prstGeom prst="rect">
             <a:avLst/>
@@ -4431,7 +4449,7 @@
               <a:buNone/>
             </a:pPr>
             <a:r>
-              <a:rPr lang="en-US" sz="1100" dirty="0">
+              <a:rPr lang="en-US" sz="1150" dirty="0">
                 <a:solidFill>
                   <a:srgbClr val="626365"/>
                 </a:solidFill>
@@ -4441,7 +4459,7 @@
               </a:rPr>
               <a:t>fits residuals r₁</a:t>
             </a:r>
-            <a:endParaRPr lang="en-US" sz="1100" dirty="0"/>
+            <a:endParaRPr lang="en-US" sz="1150" dirty="0"/>
           </a:p>
         </p:txBody>
       </p:sp>
@@ -4453,8 +4471,8 @@
         </p:nvSpPr>
         <p:spPr>
           <a:xfrm>
-            <a:off x="7978140" y="3766414"/>
-            <a:ext cx="1103681" cy="0"/>
+            <a:off x="8305495" y="3762756"/>
+            <a:ext cx="1153058" cy="0"/>
           </a:xfrm>
           <a:prstGeom prst="line">
             <a:avLst/>
@@ -4477,8 +4495,8 @@
         </p:nvSpPr>
         <p:spPr>
           <a:xfrm>
-            <a:off x="7978140" y="3334817"/>
-            <a:ext cx="1103681" cy="276149"/>
+            <a:off x="8305495" y="3311042"/>
+            <a:ext cx="1153058" cy="288036"/>
           </a:xfrm>
           <a:prstGeom prst="rect">
             <a:avLst/>
@@ -4494,7 +4512,7 @@
               <a:buNone/>
             </a:pPr>
             <a:r>
-              <a:rPr lang="en-US" sz="1100" dirty="0">
+              <a:rPr lang="en-US" sz="1150" dirty="0">
                 <a:solidFill>
                   <a:srgbClr val="262626"/>
                 </a:solidFill>
@@ -4504,7 +4522,7 @@
               </a:rPr>
               <a:t>r₂</a:t>
             </a:r>
-            <a:endParaRPr lang="en-US" sz="1100" dirty="0"/>
+            <a:endParaRPr lang="en-US" sz="1150" dirty="0"/>
           </a:p>
         </p:txBody>
       </p:sp>
@@ -4516,12 +4534,12 @@
         </p:nvSpPr>
         <p:spPr>
           <a:xfrm>
-            <a:off x="9080906" y="3260750"/>
-            <a:ext cx="1747418" cy="1011326"/>
+            <a:off x="9457639" y="3234233"/>
+            <a:ext cx="1825142" cy="1056132"/>
           </a:xfrm>
           <a:prstGeom prst="roundRect">
             <a:avLst>
-              <a:gd name="adj" fmla="val 5425"/>
+              <a:gd name="adj" fmla="val 5195"/>
             </a:avLst>
           </a:prstGeom>
           <a:solidFill>
@@ -4537,7 +4555,7 @@
               <a:buNone/>
             </a:pPr>
             <a:r>
-              <a:rPr lang="en-US" sz="1300" b="1" dirty="0">
+              <a:rPr lang="en-US" sz="1350" b="1" dirty="0">
                 <a:solidFill>
                   <a:srgbClr val="FFFFFF"/>
                 </a:solidFill>
@@ -4547,14 +4565,14 @@
               </a:rPr>
               <a:t>Tree 3</a:t>
             </a:r>
-            <a:endParaRPr lang="en-US" sz="1300" dirty="0"/>
+            <a:endParaRPr lang="en-US" sz="1350" dirty="0"/>
           </a:p>
           <a:p>
             <a:pPr algn="ctr" indent="0" marL="0">
               <a:buNone/>
             </a:pPr>
             <a:r>
-              <a:rPr lang="en-US" sz="1300" b="1" dirty="0">
+              <a:rPr lang="en-US" sz="1350" b="1" dirty="0">
                 <a:solidFill>
                   <a:srgbClr val="FFFFFF"/>
                 </a:solidFill>
@@ -4564,7 +4582,7 @@
               </a:rPr>
               <a:t>f₃(x)  …</a:t>
             </a:r>
-            <a:endParaRPr lang="en-US" sz="1300" dirty="0"/>
+            <a:endParaRPr lang="en-US" sz="1350" dirty="0"/>
           </a:p>
         </p:txBody>
       </p:sp>
@@ -4576,8 +4594,8 @@
         </p:nvSpPr>
         <p:spPr>
           <a:xfrm>
-            <a:off x="8897112" y="4410151"/>
-            <a:ext cx="2115007" cy="321869"/>
+            <a:off x="9265615" y="4434840"/>
+            <a:ext cx="2209190" cy="336499"/>
           </a:xfrm>
           <a:prstGeom prst="rect">
             <a:avLst/>
@@ -4593,7 +4611,7 @@
               <a:buNone/>
             </a:pPr>
             <a:r>
-              <a:rPr lang="en-US" sz="1100" dirty="0">
+              <a:rPr lang="en-US" sz="1150" dirty="0">
                 <a:solidFill>
                   <a:srgbClr val="626365"/>
                 </a:solidFill>
@@ -4603,7 +4621,7 @@
               </a:rPr>
               <a:t>fits residuals r₂</a:t>
             </a:r>
-            <a:endParaRPr lang="en-US" sz="1100" dirty="0"/>
+            <a:endParaRPr lang="en-US" sz="1150" dirty="0"/>
           </a:p>
         </p:txBody>
       </p:sp>
@@ -4615,8 +4633,8 @@
         </p:nvSpPr>
         <p:spPr>
           <a:xfrm>
-            <a:off x="1172261" y="5284318"/>
-            <a:ext cx="9379915" cy="0"/>
+            <a:off x="1196950" y="5347411"/>
+            <a:ext cx="9796882" cy="0"/>
           </a:xfrm>
           <a:prstGeom prst="line">
             <a:avLst/>
@@ -4638,8 +4656,8 @@
         </p:nvSpPr>
         <p:spPr>
           <a:xfrm>
-            <a:off x="620878" y="5468112"/>
-            <a:ext cx="10483596" cy="459943"/>
+            <a:off x="620878" y="5539435"/>
+            <a:ext cx="10949940" cy="480060"/>
           </a:xfrm>
           <a:prstGeom prst="rect">
             <a:avLst/>
@@ -4655,7 +4673,7 @@
               <a:buNone/>
             </a:pPr>
             <a:r>
-              <a:rPr lang="en-US" sz="1400" b="1" dirty="0">
+              <a:rPr lang="en-US" sz="1450" b="1" dirty="0">
                 <a:solidFill>
                   <a:srgbClr val="262626"/>
                 </a:solidFill>
@@ -4665,7 +4683,7 @@
               </a:rPr>
               <a:t>Final prediction:  F(x) = f₁(x) + η·f₂(x) + η·f₃(x) + …    (η = learning rate, shrinks each correction)</a:t>
             </a:r>
-            <a:endParaRPr lang="en-US" sz="1400" dirty="0"/>
+            <a:endParaRPr lang="en-US" sz="1450" dirty="0"/>
           </a:p>
         </p:txBody>
       </p:sp>
@@ -4716,6 +4734,9 @@
           <a:lstStyle/>
           <a:p>
             <a:pPr algn="l" indent="0" marL="0">
+              <a:lnSpc>
+                <a:spcPct val="90000"/>
+              </a:lnSpc>
               <a:buNone/>
             </a:pPr>
             <a:r>

</xml_diff>